<commit_message>
feat: iBEC E1/E2/Tau bounded evidence round + statecontrast_v2 scaffolding + submission v2 build
- E1 generator behavior audit (20 components x 5 arms x 3 seeds): BFN expanded
  H3 exploration (entropy/Hamming CIs exclude zero) with developability tradeoff
- E2 IDP evidence audit: deprecate "800+ natural IDPs", corrected to 1,289
  five-conformation records / 219 with exact-sequence DisProt evidence
- Tau 5MP3 sanity pass + 8-candidate shortlist (go decision for second target)
- Force-track frozen evidence JSONs: results/ibec/*, multiscaffold_confirmatory_v2
  raw generation/audit, holdout manifest (SHA256-referenced by E1 config)
- statecontrast_v2 module/dataset/contract + cross-validation tooling
- ~70 new tests, benchmark configs, analysis/audit scripts
- iBEC v2 submission package (report + 10-page abstract, deadline 2026-09-30)
- Remove legacy debug scripts and idp_4hix_final_report.json; ignore
  reviewer_outputs/ and Office temp files
</commit_message>
<xml_diff>
--- a/iBEC_Submission/28-解析无序-技术摘要.pptx
+++ b/iBEC_Submission/28-解析无序-技术摘要.pptx
@@ -3607,7 +3607,7 @@
               </a:defRPr>
             </a:pPr>
             <a:r>
-              <a:t>• T2.1 v2 achieves 96.2% valid structures with 100% positive contact recovery (0.581)</a:t>
+              <a:t>• T2.1 v2: 80.6% valid overall; random control 0.619 vs supplied 0.581</a:t>
             </a:r>
           </a:p>
           <a:p>
@@ -6624,7 +6624,7 @@
                         </a:defRPr>
                       </a:pPr>
                       <a:r>
-                        <a:t>Valid structures after recovery</a:t>
+                        <a:t>Valid structures overall</a:t>
                       </a:r>
                     </a:p>
                   </a:txBody>
@@ -6648,7 +6648,7 @@
                         </a:defRPr>
                       </a:pPr>
                       <a:r>
-                        <a:t>25/26 (96.2%)</a:t>
+                        <a:t>25/31 (80.6%)</a:t>
                       </a:r>
                     </a:p>
                   </a:txBody>
@@ -6889,7 +6889,7 @@
               </a:defRPr>
             </a:pPr>
             <a:r>
-              <a:t>T2 (failed) vs T2.1 v2 (success)</a:t>
+              <a:t>T2 vs T2.1 v2 (recalibrated)</a:t>
             </a:r>
           </a:p>
         </p:txBody>
@@ -6934,7 +6934,7 @@
             <a:br/>
             <a:br/>
             <a:r>
-              <a:t>T2.1 v2:  25/26 valid, recovery = 0.581</a:t>
+              <a:t>T2.1 v2:  25/31 valid, recovery = 0.581</a:t>
             </a:r>
             <a:br/>
             <a:r>
@@ -6943,11 +6943,11 @@
             <a:br/>
             <a:br/>
             <a:r>
-              <a:t>Root cause: parameter calibration, not</a:t>
+              <a:t>Random restraint recovery = 0.619;</a:t>
             </a:r>
             <a:br/>
             <a:r>
-              <a:t>fundamental method limitation.</a:t>
+              <a:t>contact-specific mechanism unsupported.</a:t>
             </a:r>
           </a:p>
         </p:txBody>
@@ -7026,7 +7026,7 @@
               </a:defRPr>
             </a:pPr>
             <a:r>
-              <a:t>Gate pass: 96.2% valid structures, 100% positive contact recovery, mean recovery 0.581</a:t>
+              <a:t>80.6% valid overall; random restraints outperform supplied contacts (0.619 vs 0.581)</a:t>
             </a:r>
           </a:p>
         </p:txBody>
@@ -7131,7 +7131,7 @@
               </a:defRPr>
             </a:pPr>
             <a:r>
-              <a:t>6. 4HIX IDP Antibody Design Validation</a:t>
+              <a:t>6. 4HIX ProteinMPNN Computational Case Study</a:t>
             </a:r>
           </a:p>
         </p:txBody>
@@ -8229,7 +8229,7 @@
               </a:defRPr>
             </a:pPr>
             <a:r>
-              <a:t>• Best design: ipTM = 0.462 (+2.9%)</a:t>
+              <a:t>• Best design: ipTM = 0.462 (+2.8%, descriptive difference)</a:t>
             </a:r>
           </a:p>
           <a:p>
@@ -8875,7 +8875,7 @@
               </a:defRPr>
             </a:pPr>
             <a:r>
-              <a:t>n=31 structures, 96.2% valid</a:t>
+              <a:t>n=31 structures, 80.6% valid</a:t>
             </a:r>
           </a:p>
         </p:txBody>
@@ -8911,7 +8911,7 @@
               </a:defRPr>
             </a:pPr>
             <a:r>
-              <a:t>Physical contact recovery (0.581)</a:t>
+              <a:t>Random control higher than supplied</a:t>
             </a:r>
           </a:p>
         </p:txBody>
@@ -9980,7 +9980,7 @@
             </a:r>
             <a:br/>
             <a:r>
-              <a:t>3. T2.1 perturbation: peptide restraint 25 -&gt; 100 kJ/mol/nm2 improved valid fraction from 43% to 96.2%.</a:t>
+              <a:t>3. T2.1 perturbation: recalibrated protocol reached 80.6% overall validity; mechanism unsupported.</a:t>
             </a:r>
           </a:p>
         </p:txBody>

</xml_diff>